<commit_message>
Calls templates: PowerPoint opens without repair; filler handles Excel-edited templates
- PowerPoint template: slide 3's two charts were placed at decimal positions, which PowerPoint rejects
  ("repair"); remade with whole numbers. Speaker notes no longer carry the box-sizing stand-in text. The
  template maker now remakes one template at a time, so it can't overwrite a hand-edited one.
- Excel template: Nathan's redesign (card layout, chart helper blocks, data bars).
- fill.js: ignores formula results Excel saved with slot text in them, allows empty formatted rows below a
  repeating row, clears chart caches before filling. Local previews fetch fresh export files each load.
- Publish check: finds headline figures below their labels (card layouts); fails any deck with a decimal
  position or size.

Co-Authored-By: Claude Opus 5.5 <noreply@anthropic.com>
</commit_message>
<xml_diff>
--- a/assets/exports/templates/calls.pptx
+++ b/assets/exports/templates/calls.pptx
@@ -1104,7 +1104,7 @@
           <a:lstStyle/>
           <a:p>
             <a:r>
-              <a:t>{{question}}. {{business}}. §intro§ lorem§intro§ lorem§intro§ lorem§intro§ lorem§intro§ lorem§intro§ lorem§intro§ lorem§intro§ lorem§intro§ lorem§intro§ lorem§intro§ lorem§intro§ lorem§intro§ lorem§intro§ lorem§intro§ lorem§intro§ lorem§intro§ lorem§intro§ lorem§intro§ lorem§intro§ lorem§intro§ lorem§intro§ lorem§intro§ lorem§intro§ lorem§intro§ lorem</a:t>
+              <a:t>{{question}}. {{business}}. Period: {{period_label}}. In short: {{answer}} {{intro}}</a:t>
             </a:r>
           </a:p>
         </p:txBody>
@@ -6133,7 +6133,7 @@
         </p:nvGraphicFramePr>
         <p:xfrm>
           <a:off x="457200" y="1507236"/>
-          <a:ext cx="11277295" cy="2035302.0"/>
+          <a:ext cx="11277295" cy="2035302"/>
         </p:xfrm>
         <a:graphic>
           <a:graphicData uri="http://schemas.openxmlformats.org/drawingml/2006/chart">
@@ -6189,8 +6189,8 @@
           <p:nvPr/>
         </p:nvGraphicFramePr>
         <p:xfrm>
-          <a:off x="457200" y="3862578.0"/>
-          <a:ext cx="11277295" cy="2035302.0"/>
+          <a:off x="457200" y="3862578"/>
+          <a:ext cx="11277295" cy="2035302"/>
         </p:xfrm>
         <a:graphic>
           <a:graphicData uri="http://schemas.openxmlformats.org/drawingml/2006/chart">

</xml_diff>